<commit_message>
Refresh EDA pipeline outputs and add app-level base metrics
- Re-run EDA Section A-E against current cleansed English subset.
- Update workbooks and bilingual conclusion PDF/PPT.
- Add build_app_base_metrics.py and config (metrics.json, benchmark_flagship.json).

Co-authored-by: Cursor <cursoragent@cursor.com>
</commit_message>
<xml_diff>
--- a/google play/reports/EDA_Conclusion_Bilingual.pptx
+++ b/google play/reports/EDA_Conclusion_Bilingual.pptx
@@ -3138,7 +3138,7 @@
               <a:defRPr sz="1400"/>
             </a:pPr>
             <a:r>
-              <a:t>Sciencia AI / Mentor update · Apr 2026</a:t>
+              <a:t>Figures from quality_report.csv + A5_data_scale_chain.csv · 2026-05-05 16:26:06</a:t>
             </a:r>
           </a:p>
         </p:txBody>
@@ -3225,7 +3225,7 @@
               <a:defRPr sz="1400"/>
             </a:pPr>
             <a:r>
-              <a:t>• Built an English analysis set of **10,072** reviews (≥10k target met).</a:t>
+              <a:t>• Built an English analysis set of **10,940** reviews (≥10k target met).</a:t>
             </a:r>
           </a:p>
           <a:p>
@@ -3233,7 +3233,7 @@
               <a:defRPr sz="1200"/>
             </a:pPr>
             <a:r>
-              <a:t>  构建英文分析集 **10,072** 条，满足 mentor 提出的 **10k+** 规模要求。</a:t>
+              <a:t>  构建英文分析集 **10,940** 条，满足 mentor 提出的 **10k+** 规模要求。</a:t>
             </a:r>
           </a:p>
           <a:p>
@@ -3358,7 +3358,7 @@
               <a:defRPr sz="1400"/>
             </a:pPr>
             <a:r>
-              <a:t>• Raw rows: **15,390** (`google_play_reviews_raw.xlsx`)</a:t>
+              <a:t>• Raw rows: **16,800** (`google_play_reviews_raw.csv`)</a:t>
             </a:r>
           </a:p>
           <a:p>
@@ -3366,7 +3366,7 @@
               <a:defRPr sz="1200"/>
             </a:pPr>
             <a:r>
-              <a:t>  原始数据：**15,390** 行</a:t>
+              <a:t>  原始数据：**16,800** 行（`google_play_reviews_raw.csv`）</a:t>
             </a:r>
           </a:p>
           <a:p>
@@ -3377,7 +3377,7 @@
               <a:defRPr sz="1400"/>
             </a:pPr>
             <a:r>
-              <a:t>• After P0 (all languages): **13,879** (`clean_all_languages.xlsx`)</a:t>
+              <a:t>• After P0 (all languages): **15,290** (`clean_all_languages.csv`)</a:t>
             </a:r>
           </a:p>
           <a:p>
@@ -3385,7 +3385,7 @@
               <a:defRPr sz="1200"/>
             </a:pPr>
             <a:r>
-              <a:t>  P0 后全语言：**13,879** 行</a:t>
+              <a:t>  P0 后全语言：**15,290** 行（`clean_all_languages.csv`）</a:t>
             </a:r>
           </a:p>
           <a:p>
@@ -3396,7 +3396,7 @@
               <a:defRPr sz="1400"/>
             </a:pPr>
             <a:r>
-              <a:t>• After P0 + English filter: **10,072** (`clean_en_only.xlsx`)</a:t>
+              <a:t>• After P0 + English filter: **10,940** (`clean_en_only.csv`)</a:t>
             </a:r>
           </a:p>
           <a:p>
@@ -3404,7 +3404,7 @@
               <a:defRPr sz="1200"/>
             </a:pPr>
             <a:r>
-              <a:t>  P0 + 英文子集：**10,072** 行</a:t>
+              <a:t>  P0 + 英文子集：**10,940** 行（`clean_en_only.csv`）</a:t>
             </a:r>
           </a:p>
           <a:p>
@@ -3415,7 +3415,7 @@
               <a:defRPr sz="1400"/>
             </a:pPr>
             <a:r>
-              <a:t>• English share on P0-all-lang set: ~**72.6%** (`is_en` / langdetect)</a:t>
+              <a:t>• English share on P0-all-lang set: ~**71.5%** (`is_en` / langdetect)</a:t>
             </a:r>
           </a:p>
           <a:p>
@@ -3423,7 +3423,7 @@
               <a:defRPr sz="1200"/>
             </a:pPr>
             <a:r>
-              <a:t>  P0 全语言集中英文占比约 **72.6%**（`is_en` / 语言检测）</a:t>
+              <a:t>  P0 全语言集中英文占比约 **71.5%**（`is_en` / 语言检测）</a:t>
             </a:r>
           </a:p>
         </p:txBody>

</xml_diff>